<commit_message>
fix: update working Catalyst deployment
</commit_message>
<xml_diff>
--- a/Ibha_KSP_Prototype_Submission.pptx
+++ b/Ibha_KSP_Prototype_Submission.pptx
@@ -849,7 +849,7 @@
         </p:nvSpPr>
         <p:spPr>
           <a:xfrm>
-            <a:off x="381300" y="685800"/>
+            <a:off x="381000" y="685800"/>
             <a:ext cx="6096000" cy="3429000"/>
           </a:xfrm>
           <a:custGeom>
@@ -953,7 +953,7 @@
         </p:nvSpPr>
         <p:spPr>
           <a:xfrm>
-            <a:off x="381300" y="685800"/>
+            <a:off x="381000" y="685800"/>
             <a:ext cx="6096000" cy="3429000"/>
           </a:xfrm>
           <a:custGeom>
@@ -1057,7 +1057,7 @@
         </p:nvSpPr>
         <p:spPr>
           <a:xfrm>
-            <a:off x="381300" y="685800"/>
+            <a:off x="381000" y="685800"/>
             <a:ext cx="6096000" cy="3429000"/>
           </a:xfrm>
           <a:custGeom>
@@ -1265,7 +1265,7 @@
         </p:nvSpPr>
         <p:spPr>
           <a:xfrm>
-            <a:off x="381300" y="685800"/>
+            <a:off x="381000" y="685800"/>
             <a:ext cx="6096000" cy="3429000"/>
           </a:xfrm>
           <a:custGeom>
@@ -1369,7 +1369,7 @@
         </p:nvSpPr>
         <p:spPr>
           <a:xfrm>
-            <a:off x="381300" y="685800"/>
+            <a:off x="381000" y="685800"/>
             <a:ext cx="6096000" cy="3429000"/>
           </a:xfrm>
           <a:custGeom>
@@ -1473,7 +1473,7 @@
         </p:nvSpPr>
         <p:spPr>
           <a:xfrm>
-            <a:off x="381300" y="685800"/>
+            <a:off x="381000" y="685800"/>
             <a:ext cx="6096000" cy="3429000"/>
           </a:xfrm>
           <a:custGeom>
@@ -1577,7 +1577,7 @@
         </p:nvSpPr>
         <p:spPr>
           <a:xfrm>
-            <a:off x="381300" y="685800"/>
+            <a:off x="381000" y="685800"/>
             <a:ext cx="6096000" cy="3429000"/>
           </a:xfrm>
           <a:custGeom>
@@ -1681,7 +1681,7 @@
         </p:nvSpPr>
         <p:spPr>
           <a:xfrm>
-            <a:off x="381300" y="685800"/>
+            <a:off x="381000" y="685800"/>
             <a:ext cx="6096000" cy="3429000"/>
           </a:xfrm>
           <a:custGeom>
@@ -1785,7 +1785,7 @@
         </p:nvSpPr>
         <p:spPr>
           <a:xfrm>
-            <a:off x="381300" y="685800"/>
+            <a:off x="381000" y="685800"/>
             <a:ext cx="6096000" cy="3429000"/>
           </a:xfrm>
           <a:custGeom>
@@ -1889,7 +1889,7 @@
         </p:nvSpPr>
         <p:spPr>
           <a:xfrm>
-            <a:off x="381300" y="685800"/>
+            <a:off x="381000" y="685800"/>
             <a:ext cx="6096000" cy="3429000"/>
           </a:xfrm>
           <a:custGeom>
@@ -1993,7 +1993,7 @@
         </p:nvSpPr>
         <p:spPr>
           <a:xfrm>
-            <a:off x="381300" y="685800"/>
+            <a:off x="381000" y="685800"/>
             <a:ext cx="6096000" cy="3429000"/>
           </a:xfrm>
           <a:custGeom>
@@ -2097,7 +2097,7 @@
         </p:nvSpPr>
         <p:spPr>
           <a:xfrm>
-            <a:off x="381300" y="685800"/>
+            <a:off x="381000" y="685800"/>
             <a:ext cx="6096000" cy="3429000"/>
           </a:xfrm>
           <a:custGeom>
@@ -2201,7 +2201,7 @@
         </p:nvSpPr>
         <p:spPr>
           <a:xfrm>
-            <a:off x="381300" y="685800"/>
+            <a:off x="381000" y="685800"/>
             <a:ext cx="6096000" cy="3429000"/>
           </a:xfrm>
           <a:custGeom>
@@ -2305,7 +2305,7 @@
         </p:nvSpPr>
         <p:spPr>
           <a:xfrm>
-            <a:off x="381300" y="685800"/>
+            <a:off x="381000" y="685800"/>
             <a:ext cx="6096000" cy="3429000"/>
           </a:xfrm>
           <a:custGeom>
@@ -7195,14 +7195,32 @@
           <a:p>
             <a:r>
               <a:rPr dirty="0"/>
-              <a:t>• Team Name:</a:t>
-            </a:r>
+              <a:t>• Team Name</a:t>
+            </a:r>
+            <a:r>
+              <a:rPr dirty="0" smtClean="0"/>
+              <a:t>:</a:t>
+            </a:r>
+            <a:r>
+              <a:rPr lang="en-US" dirty="0" smtClean="0"/>
+              <a:t> </a:t>
+            </a:r>
+            <a:r>
+              <a:rPr lang="en-US" dirty="0" err="1" smtClean="0"/>
+              <a:t>Avighna</a:t>
+            </a:r>
+            <a:endParaRPr dirty="0"/>
           </a:p>
           <a:p>
             <a:r>
               <a:rPr dirty="0"/>
               <a:t>• Team Leader Name: </a:t>
             </a:r>
+            <a:r>
+              <a:rPr lang="en-US" dirty="0" smtClean="0"/>
+              <a:t>Bhakti Parulekar</a:t>
+            </a:r>
+            <a:endParaRPr dirty="0"/>
           </a:p>
           <a:p>
             <a:r>
@@ -7502,6 +7520,9 @@
             </a:r>
           </a:p>
           <a:p>
+            <a:r>
+              <a:t/>
+            </a:r>
             <a:br/>
             <a:r>
               <a:t>• End-to-End Chat Latency: ~700ms average (Intent extraction + SQL + NL answer synthesis).</a:t>
@@ -7605,6 +7626,10 @@
             </a:r>
           </a:p>
           <a:p>
+            <a:r>
+              <a:rPr dirty="0"/>
+              <a:t/>
+            </a:r>
             <a:br>
               <a:rPr dirty="0"/>
             </a:br>
@@ -7960,6 +7985,9 @@
             </a:r>
           </a:p>
           <a:p>
+            <a:r>
+              <a:t/>
+            </a:r>
             <a:br/>
             <a:r>
               <a:t>Key Innovations:</a:t>
@@ -8066,6 +8094,9 @@
             </a:r>
           </a:p>
           <a:p>
+            <a:r>
+              <a:t/>
+            </a:r>
             <a:br/>
             <a:r>
               <a:t>How is it different from existing solutions?</a:t>
@@ -8075,6 +8106,9 @@
               <a:t>• Most LLM platforms allow the model to generate SQL directly, risking prompt injection and schema hallucinations. Ibha separates intent extraction from SQL execution completely.</a:t>
             </a:r>
             <a:br/>
+            <a:r>
+              <a:t/>
+            </a:r>
             <a:br/>
             <a:r>
               <a:t>How will it solve the problem?</a:t>
@@ -8084,6 +8118,9 @@
               <a:t>• Police officers can query complex databases using plain voice/text in their regional language, while security automatically enforces Row-Level Security (RLS) based on jurisdiction.</a:t>
             </a:r>
             <a:br/>
+            <a:r>
+              <a:t/>
+            </a:r>
             <a:br/>
             <a:r>
               <a:t>USP of Ibha:</a:t>
@@ -8186,6 +8223,9 @@
             </a:r>
           </a:p>
           <a:p>
+            <a:r>
+              <a:t/>
+            </a:r>
             <a:br/>
             <a:r>
               <a:t>1. Pillar 1 (Conversational AI): Multi-turn chat in English &amp; Kannada.</a:t>
@@ -8312,6 +8352,9 @@
             </a:r>
           </a:p>
           <a:p>
+            <a:r>
+              <a:t/>
+            </a:r>
             <a:br/>
             <a:r>
               <a:t>[Officer Query (Text/Voice)]</a:t>
@@ -8557,6 +8600,9 @@
             </a:r>
           </a:p>
           <a:p>
+            <a:r>
+              <a:t/>
+            </a:r>
             <a:br/>
             <a:r>
               <a:t>• Client Layer: Next.js 14 (App Router), Tailwind CSS, Recharts, Cytoscape.js, Self-hosted Noto Sans Kannada.</a:t>
@@ -8663,6 +8709,9 @@
             </a:r>
           </a:p>
           <a:p>
+            <a:r>
+              <a:t/>
+            </a:r>
             <a:br/>
             <a:r>
               <a:t>• Frontend: Next.js 14, React 18, Tailwind CSS, Recharts, Cytoscape.js, Lucide Icons.</a:t>
@@ -8773,6 +8822,9 @@
             </a:r>
           </a:p>
           <a:p>
+            <a:r>
+              <a:t/>
+            </a:r>
             <a:br/>
             <a:r>
               <a:t>1. Catalyst Serverless Functions: Target runtime for backend handlers (health, chat, audit, insights, support, trends, network).</a:t>

</xml_diff>